<commit_message>
Add W04 lab sheet and rebuild W04 deck for the four-person cohort
- labs/Lab-04-W04-Finding-Actors-and-Use-Cases.md: Exercise 4.1 (actors, nine candidates), Exercise 4.2 (diagram + one sentence per dashed arrow), 15-min defence to the instructor as client, push-only submission (M1 tag on Oct 4)
- Lab Guide: Lab 4 entry now links the lab sheet and states today's deliverable
- W04 deck rebuilt: removed the two-team assumptions, corrected the M1 date line (Sun Oct 4)
</commit_message>
<xml_diff>
--- a/01-slides/W04-Requirements-and-Use-Case-Modeling.pptx
+++ b/01-slides/W04-Requirements-and-Use-Case-Modeling.pptx
@@ -21643,7 +21643,7 @@
   <p:cSld>
     <p:spTree>
       <p:nvGrpSpPr>
-        <p:cNvPr id="519" name="" descr="&lt;Slide style={{ background: '#FFFFFF', padding: 0 }}&gt;&#10;  &lt;Box style={{ height: 72, background: '#1E4FA8', padding: '0 40px', flexDirection: 'row', alignItems: 'center', justifyContent: 'space-between' }}&gt;&#10;    &lt;Text style={{ fontSize: 15, color: '#B9CDF0', letterSpacing: 1 }}&gt;ISAD · INFORMATION SYSTEMS ANALYSIS &amp;amp; DESIGN&lt;/Text&gt;&#10;    &lt;Text style={{ fontSize: 15, color: '#B9CDF0' }}&gt;W04 · FINDING USE CASES&lt;/Text&gt;&#10;  &lt;/Box&gt;&#10;  &lt;Box style={{ padding: '14px 40px 0 40px', flexDirection: 'row', alignItems: 'center', justifyContent: 'space-between' }}&gt;&#10;    &lt;Text style={{ fontSize: 29, fontWeight: 'bold', color: '#0E3F8C' }}&gt;What We Have Not Done Yet&lt;/Text&gt;&#10;    &lt;Text style={{ fontSize: 14, color: '#1E4FA8', fontWeight: 'bold' }}&gt;29 / 38&lt;/Text&gt;&#10;  &lt;/Box&gt;&#10;  &lt;Box style={{ flex: 1, padding: '16px 60px 0 60px', flexDirection: 'column', justifyContent: 'center', alignItems: 'center' }}&gt;&#10;    &lt;Box style={{ width: 960, padding: '20px 30px', background: '#FFF6E0', borderRadius: 10, borderLeft: '6px solid #FFC107', marginBottom: 20 }}&gt;&#10;      &lt;Text style={{ fontSize: 23, color: '#0E3F8C', fontWeight: 'bold', lineHeight: 1.4, textAlign: 'center' }}&gt;&#10;        A named ellipse is a promise to write something.&#10;        &lt;br /&gt;&#10;        The promise is kept next week.&#10;      &lt;/Text&gt;&#10;    &lt;/Box&gt;&#10;    &lt;Box style={{ width: 960, flexDirection: 'row', gap: 18 }}&gt;&#10;      &lt;Box style={{ flex: 1, padding: '20px 18px', background: '#FFFFFF', borderRadius: 10, border: '1px solid #D6DCE5' }}&gt;&#10;        &lt;Box style={{ flexDirection: 'row', alignItems: 'center', gap: 8, marginBottom: 8 }}&gt;&#10;          &lt;FAIcon name='info-circle' style={{ fill: '#1E4FA8', width: 20, height: 20 }} /&gt;&#10;          &lt;Text style={{ fontSize: 16, fontWeight: 'bold', color: '#0E3F8C' }}&gt;Not yet: the use case text&lt;/Text&gt;&#10;        &lt;/Box&gt;&#10;        &lt;Text style={{ fontSize: 12.8, color: '#4A5568', lineHeight: 1.65 }}&gt;&#10;          “Place Order” on a diagram tells you a goal exists. It does not tell you what happens when the card is declined, or what must be true before the student starts. That is the use case specification — &lt;Text style={{ fontWeight: 'bold', color: '#0E3F8C' }}&gt;Week 05&lt;/Text&gt;.&#10;        &lt;/Text&gt;&#10;      &lt;/Box&gt;&#10;      &lt;Box style={{ flex: 1, padding: '20px 18px', background: '#FFFFFF', borderRadius: 10, border: '1px solid #D6DCE5' }}&gt;&#10;        &lt;Box style={{ flexDirection: 'row', alignItems: 'center', gap: 8, marginBottom: 8 }}&gt;&#10;          &lt;FAIcon name='layer-group' style={{ fill: '#1E4FA8', width: 20, height: 20 }} /&gt;&#10;          &lt;Text style={{ fontSize: 16, fontWeight: 'bold', color: '#0E3F8C' }}&gt;Not yet: the domain model&lt;/Text&gt;&#10;        &lt;/Box&gt;&#10;        &lt;Text style={{ fontSize: 12.8, color: '#4A5568', lineHeight: 1.65 }}&gt;&#10;          Order, MenuItem and Courier are names on this page. Turning them into classes with attributes and associations is a different artefact — &lt;Text style={{ fontWeight: 'bold', color: '#0E3F8C' }}&gt;Week 06&lt;/Text&gt;. Resist the urge to draw boxes today.&#10;        &lt;/Text&gt;&#10;      &lt;/Box&gt;&#10;      &lt;Box style={{ flex: 1, padding: '20px 18px', background: '#F0F5FC', borderRadius: 10, border: '1px solid #1E4FA8' }}&gt;&#10;        &lt;Box style={{ flexDirection: 'row', alignItems: 'center', gap: 8, marginBottom: 8 }}&gt;&#10;          &lt;FAIcon name='handshake' style={{ fill: '#1E4FA8', width: 20, height: 20 }} /&gt;&#10;          &lt;Text style={{ fontSize: 16, fontWeight: 'bold', color: '#0E3F8C' }}&gt;Next week: you are the client&lt;/Text&gt;&#10;        &lt;/Box&gt;&#10;        &lt;Text style={{ fontSize: 12.8, color: '#4A5568', lineHeight: 1.65 }}&gt;&#10;          In Week 05 the instructor plays the client and reviews your pack with you. Bring a diagram you can defend, because the other team will ask why “Manage Order” is on it.&#10;        &lt;/Text&gt;&#10;      &lt;/Box&gt;&#10;    &lt;/Box&gt;&#10;  &lt;/Box&gt;&#10;  &lt;Box style={{ height: 46, background: '#0E3F8C', padding: '0 40px', flexDirection: 'row', alignItems: 'center', justifyContent: 'center' }}&gt;&#10;    &lt;Text style={{ fontSize: 16, color: '#FFFFFF', fontWeight: '600' }}&gt;This week you find the goals. Next week you write them down so a stranger could build them.&lt;/Text&gt;&#10;  &lt;/Box&gt;&#10;&lt;/Slide&gt;"/>
+        <p:cNvPr id="519" name="" descr="&lt;Slide style={{ background: '#FFFFFF', padding: 0 }}&gt;&#10;  &lt;Box style={{ height: 72, background: '#1E4FA8', padding: '0 40px', flexDirection: 'row', alignItems: 'center', justifyContent: 'space-between' }}&gt;&#10;    &lt;Text style={{ fontSize: 15, color: '#B9CDF0', letterSpacing: 1 }}&gt;ISAD · INFORMATION SYSTEMS ANALYSIS &amp;amp; DESIGN&lt;/Text&gt;&#10;    &lt;Text style={{ fontSize: 15, color: '#B9CDF0' }}&gt;W04 · FINDING USE CASES&lt;/Text&gt;&#10;  &lt;/Box&gt;&#10;  &lt;Box style={{ padding: '14px 40px 0 40px', flexDirection: 'row', alignItems: 'center', justifyContent: 'space-between' }}&gt;&#10;    &lt;Text style={{ fontSize: 29, fontWeight: 'bold', color: '#0E3F8C' }}&gt;What We Have Not Done Yet&lt;/Text&gt;&#10;    &lt;Text style={{ fontSize: 14, color: '#1E4FA8', fontWeight: 'bold' }}&gt;29 / 38&lt;/Text&gt;&#10;  &lt;/Box&gt;&#10;  &lt;Box style={{ flex: 1, padding: '16px 60px 0 60px', flexDirection: 'column', justifyContent: 'center', alignItems: 'center' }}&gt;&#10;    &lt;Box style={{ width: 960, padding: '20px 30px', background: '#FFF6E0', borderRadius: 10, borderLeft: '6px solid #FFC107', marginBottom: 20 }}&gt;&#10;      &lt;Text style={{ fontSize: 23, color: '#0E3F8C', fontWeight: 'bold', lineHeight: 1.4, textAlign: 'center' }}&gt;&#10;        A named ellipse is a promise to write something.&#10;        &lt;br /&gt;&#10;        The promise is kept next week.&#10;      &lt;/Text&gt;&#10;    &lt;/Box&gt;&#10;    &lt;Box style={{ width: 960, flexDirection: 'row', gap: 18 }}&gt;&#10;      &lt;Box style={{ flex: 1, padding: '20px 18px', background: '#FFFFFF', borderRadius: 10, border: '1px solid #D6DCE5' }}&gt;&#10;        &lt;Box style={{ flexDirection: 'row', alignItems: 'center', gap: 8, marginBottom: 8 }}&gt;&#10;          &lt;FAIcon name='info-circle' style={{ fill: '#1E4FA8', width: 20, height: 20 }} /&gt;&#10;          &lt;Text style={{ fontSize: 16, fontWeight: 'bold', color: '#0E3F8C' }}&gt;Not yet: the use case text&lt;/Text&gt;&#10;        &lt;/Box&gt;&#10;        &lt;Text style={{ fontSize: 12.8, color: '#4A5568', lineHeight: 1.65 }}&gt;&#10;          “Place Order” on a diagram tells you a goal exists. It does not tell you what happens when the card is declined, or what must be true before the student starts. That is the use case specification — &lt;Text style={{ fontWeight: 'bold', color: '#0E3F8C' }}&gt;Week 05&lt;/Text&gt;.&#10;        &lt;/Text&gt;&#10;      &lt;/Box&gt;&#10;      &lt;Box style={{ flex: 1, padding: '20px 18px', background: '#FFFFFF', borderRadius: 10, border: '1px solid #D6DCE5' }}&gt;&#10;        &lt;Box style={{ flexDirection: 'row', alignItems: 'center', gap: 8, marginBottom: 8 }}&gt;&#10;          &lt;FAIcon name='layer-group' style={{ fill: '#1E4FA8', width: 20, height: 20 }} /&gt;&#10;          &lt;Text style={{ fontSize: 16, fontWeight: 'bold', color: '#0E3F8C' }}&gt;Not yet: the domain model&lt;/Text&gt;&#10;        &lt;/Box&gt;&#10;        &lt;Text style={{ fontSize: 12.8, color: '#4A5568', lineHeight: 1.65 }}&gt;&#10;          Order, MenuItem and Courier are names on this page. Turning them into classes with attributes and associations is a different artefact — &lt;Text style={{ fontWeight: 'bold', color: '#0E3F8C' }}&gt;Week 06&lt;/Text&gt;. Resist the urge to draw boxes today.&#10;        &lt;/Text&gt;&#10;      &lt;/Box&gt;&#10;      &lt;Box style={{ flex: 1, padding: '20px 18px', background: '#F0F5FC', borderRadius: 10, border: '1px solid #1E4FA8' }}&gt;&#10;        &lt;Box style={{ flexDirection: 'row', alignItems: 'center', gap: 8, marginBottom: 8 }}&gt;&#10;          &lt;FAIcon name='handshake' style={{ fill: '#1E4FA8', width: 20, height: 20 }} /&gt;&#10;          &lt;Text style={{ fontSize: 16, fontWeight: 'bold', color: '#0E3F8C' }}&gt;Next week: you are the client&lt;/Text&gt;&#10;        &lt;/Box&gt;&#10;        &lt;Text style={{ fontSize: 12.8, color: '#4A5568', lineHeight: 1.65 }}&gt;&#10;          In Week 05 the instructor plays the client and reviews your pack with you. Bring a diagram you can defend, because the client will ask why “Manage Order” is on it.&#10;        &lt;/Text&gt;&#10;      &lt;/Box&gt;&#10;    &lt;/Box&gt;&#10;  &lt;/Box&gt;&#10;  &lt;Box style={{ height: 46, background: '#0E3F8C', padding: '0 40px', flexDirection: 'row', alignItems: 'center', justifyContent: 'center' }}&gt;&#10;    &lt;Text style={{ fontSize: 16, color: '#FFFFFF', fontWeight: '600' }}&gt;This week you find the goals. Next week you write them down so a stranger could build them.&lt;/Text&gt;&#10;  &lt;/Box&gt;&#10;&lt;/Slide&gt;"/>
         <p:cNvGrpSpPr/>
         <p:nvPr/>
       </p:nvGrpSpPr>
@@ -22415,7 +22415,7 @@
                 <a:latin typeface="Microsoft YaHei"/>
                 <a:ea typeface="Microsoft YaHei"/>
               </a:rPr>
-              <a:t>In Week 05 the instructor plays the client and reviews your pack with you. Bring a diagram you can defend, because the other team will ask why “Manage Order” is on it.</a:t>
+              <a:t>In Week 05 the instructor plays the client and reviews your pack with you. Bring a diagram you can defend, because the client will ask why “Manage Order” is on it.</a:t>
             </a:r>
             <a:endParaRPr/>
           </a:p>
@@ -24410,7 +24410,7 @@
   <p:cSld>
     <p:spTree>
       <p:nvGrpSpPr>
-        <p:cNvPr id="592" name="" descr="&lt;Slide style={{ background: '#FFFFFF', padding: 0 }}&gt;&#10;  &lt;Box style={{ height: 72, background: '#1E4FA8', padding: '0 40px', flexDirection: 'row', alignItems: 'center', justifyContent: 'space-between' }}&gt;&#10;    &lt;Text style={{ fontSize: 15, color: '#B9CDF0', letterSpacing: 1 }}&gt;ISAD · INFORMATION SYSTEMS ANALYSIS &amp;amp; DESIGN&lt;/Text&gt;&#10;    &lt;Text style={{ fontSize: 15, color: '#B9CDF0' }}&gt;W04 · LAB · EXERCISE 4.1&lt;/Text&gt;&#10;  &lt;/Box&gt;&#10;  &lt;Box style={{ padding: '14px 40px 0 40px', flexDirection: 'row', alignItems: 'center', justifyContent: 'space-between' }}&gt;&#10;    &lt;Text style={{ fontSize: 29, fontWeight: 'bold', color: '#0E3F8C' }}&gt;Exercise 4.1 — Your Turn&lt;/Text&gt;&#10;    &lt;Text style={{ fontSize: 14, color: '#1E4FA8', fontWeight: 'bold' }}&gt;32 / 38&lt;/Text&gt;&#10;  &lt;/Box&gt;&#10;  &lt;Box style={{ flex: 1, padding: '14px 40px 0 40px', flexDirection: 'row', gap: 24 }}&gt;&#10;    &lt;Box style={{ flex: 1, flexDirection: 'column', gap: 12 }}&gt;&#10;      &lt;Box style={{ padding: '18px 18px', background: '#F0F5FC', borderRadius: 10, borderLeft: '4px solid #1E4FA8' }}&gt;&#10;        &lt;Text style={{ fontSize: 16, fontWeight: 'bold', color: '#0E3F8C' }}&gt;A · List the actors&lt;/Text&gt;&#10;        &lt;Text style={{ fontSize: 13, color: '#4A5568', lineHeight: 1.6, marginTop: 6 }}&gt;&#10;          Every role that stands outside CampusBites and talks to it. Name roles, not people — and include the systems that serve you.&#10;        &lt;/Text&gt;&#10;        &lt;Text style={{ fontSize: 12.5, color: '#8B97A8', marginTop: 8 }}&gt;Target: five to seven.&lt;/Text&gt;&#10;      &lt;/Box&gt;&#10;      &lt;Box style={{ padding: '18px 18px', background: '#F0F5FC', borderRadius: 10, borderLeft: '4px solid #1E4FA8' }}&gt;&#10;        &lt;Text style={{ fontSize: 16, fontWeight: 'bold', color: '#0E3F8C' }}&gt;B · List candidate use cases&lt;/Text&gt;&#10;        &lt;Text style={{ fontSize: 13, color: '#4A5568', lineHeight: 1.6, marginTop: 6 }}&gt;&#10;          Take the verbs from the narrative and keep only those that name a goal somebody has. Write them verb plus object.&#10;        &lt;/Text&gt;&#10;        &lt;Text style={{ fontSize: 12.5, color: '#8B97A8', marginTop: 8 }}&gt;Target: nine candidates before filtering.&lt;/Text&gt;&#10;      &lt;/Box&gt;&#10;    &lt;/Box&gt;&#10;    &lt;Box style={{ flex: 1, flexDirection: 'column', gap: 12 }}&gt;&#10;      &lt;Box style={{ padding: '18px 18px', background: '#FFFFFF', borderRadius: 10, border: '1px solid #D6DCE5' }}&gt;&#10;        &lt;Text style={{ fontSize: 16, fontWeight: 'bold', color: '#0E3F8C' }}&gt;C · Mark primary and secondary&lt;/Text&gt;&#10;        &lt;Text style={{ fontSize: 13, color: '#4A5568', lineHeight: 1.6, marginTop: 6 }}&gt;&#10;          For each actor, say whether they start use cases (primary) or are called by the system (secondary). Write the goal they own.&#10;        &lt;/Text&gt;&#10;      &lt;/Box&gt;&#10;      &lt;Box style={{ padding: '18px 18px', background: '#FFFFFF', borderRadius: 10, border: '1px solid #D6DCE5' }}&gt;&#10;        &lt;Text style={{ fontSize: 16, fontWeight: 'bold', color: '#0E3F8C' }}&gt;D · Filter the candidates&lt;/Text&gt;&#10;        &lt;Text style={{ fontSize: 13, color: '#4A5568', lineHeight: 1.6, marginTop: 6 }}&gt;&#10;          For each of the nine, answer in one line: is this a user goal, or a step inside one? Keep the goals; park the steps.&#10;        &lt;/Text&gt;&#10;      &lt;/Box&gt;&#10;      &lt;Box style={{ padding: '16px 18px', background: '#FFF6E0', borderRadius: 9, border: '1px solid #FFC107' }}&gt;&#10;        &lt;Text style={{ fontSize: 13, color: '#4A5568', lineHeight: 1.6 }}&gt;&#10;          &lt;Text style={{ fontWeight: 'bold', color: '#996F00' }}&gt;Work in your team. &lt;/Text&gt;&#10;          One page, two columns, twenty-five minutes. Answers on the next two pages — do not turn the page early.&#10;        &lt;/Text&gt;&#10;      &lt;/Box&gt;&#10;    &lt;/Box&gt;&#10;  &lt;/Box&gt;&#10;  &lt;Box style={{ height: 46, background: '#0E3F8C', padding: '0 40px', flexDirection: 'row', alignItems: 'center', justifyContent: 'center' }}&gt;&#10;    &lt;Text style={{ fontSize: 16, color: '#FFFFFF', fontWeight: '600' }}&gt;Twenty-five minutes. One page per team. Then we compare — and you will disagree about at least two of them.&lt;/Text&gt;&#10;  &lt;/Box&gt;&#10;&lt;/Slide&gt;"/>
+        <p:cNvPr id="592" name="" descr="&lt;Slide style={{ background: '#FFFFFF', padding: 0 }}&gt;&#10;  &lt;Box style={{ height: 72, background: '#1E4FA8', padding: '0 40px', flexDirection: 'row', alignItems: 'center', justifyContent: 'space-between' }}&gt;&#10;    &lt;Text style={{ fontSize: 15, color: '#B9CDF0', letterSpacing: 1 }}&gt;ISAD · INFORMATION SYSTEMS ANALYSIS &amp;amp; DESIGN&lt;/Text&gt;&#10;    &lt;Text style={{ fontSize: 15, color: '#B9CDF0' }}&gt;W04 · LAB · EXERCISE 4.1&lt;/Text&gt;&#10;  &lt;/Box&gt;&#10;  &lt;Box style={{ padding: '14px 40px 0 40px', flexDirection: 'row', alignItems: 'center', justifyContent: 'space-between' }}&gt;&#10;    &lt;Text style={{ fontSize: 29, fontWeight: 'bold', color: '#0E3F8C' }}&gt;Exercise 4.1 — Your Turn&lt;/Text&gt;&#10;    &lt;Text style={{ fontSize: 14, color: '#1E4FA8', fontWeight: 'bold' }}&gt;32 / 38&lt;/Text&gt;&#10;  &lt;/Box&gt;&#10;  &lt;Box style={{ flex: 1, padding: '14px 40px 0 40px', flexDirection: 'row', gap: 24 }}&gt;&#10;    &lt;Box style={{ flex: 1, flexDirection: 'column', gap: 12 }}&gt;&#10;      &lt;Box style={{ padding: '18px 18px', background: '#F0F5FC', borderRadius: 10, borderLeft: '4px solid #1E4FA8' }}&gt;&#10;        &lt;Text style={{ fontSize: 16, fontWeight: 'bold', color: '#0E3F8C' }}&gt;A · List the actors&lt;/Text&gt;&#10;        &lt;Text style={{ fontSize: 13, color: '#4A5568', lineHeight: 1.6, marginTop: 6 }}&gt;&#10;          Every role that stands outside CampusBites and talks to it. Name roles, not people — and include the systems that serve you.&#10;        &lt;/Text&gt;&#10;        &lt;Text style={{ fontSize: 12.5, color: '#8B97A8', marginTop: 8 }}&gt;Target: five to seven.&lt;/Text&gt;&#10;      &lt;/Box&gt;&#10;      &lt;Box style={{ padding: '18px 18px', background: '#F0F5FC', borderRadius: 10, borderLeft: '4px solid #1E4FA8' }}&gt;&#10;        &lt;Text style={{ fontSize: 16, fontWeight: 'bold', color: '#0E3F8C' }}&gt;B · List candidate use cases&lt;/Text&gt;&#10;        &lt;Text style={{ fontSize: 13, color: '#4A5568', lineHeight: 1.6, marginTop: 6 }}&gt;&#10;          Take the verbs from the narrative and keep only those that name a goal somebody has. Write them verb plus object.&#10;        &lt;/Text&gt;&#10;        &lt;Text style={{ fontSize: 12.5, color: '#8B97A8', marginTop: 8 }}&gt;Target: nine candidates before filtering.&lt;/Text&gt;&#10;      &lt;/Box&gt;&#10;    &lt;/Box&gt;&#10;    &lt;Box style={{ flex: 1, flexDirection: 'column', gap: 12 }}&gt;&#10;      &lt;Box style={{ padding: '18px 18px', background: '#FFFFFF', borderRadius: 10, border: '1px solid #D6DCE5' }}&gt;&#10;        &lt;Text style={{ fontSize: 16, fontWeight: 'bold', color: '#0E3F8C' }}&gt;C · Mark primary and secondary&lt;/Text&gt;&#10;        &lt;Text style={{ fontSize: 13, color: '#4A5568', lineHeight: 1.6, marginTop: 6 }}&gt;&#10;          For each actor, say whether they start use cases (primary) or are called by the system (secondary). Write the goal they own.&#10;        &lt;/Text&gt;&#10;      &lt;/Box&gt;&#10;      &lt;Box style={{ padding: '18px 18px', background: '#FFFFFF', borderRadius: 10, border: '1px solid #D6DCE5' }}&gt;&#10;        &lt;Text style={{ fontSize: 16, fontWeight: 'bold', color: '#0E3F8C' }}&gt;D · Filter the candidates&lt;/Text&gt;&#10;        &lt;Text style={{ fontSize: 13, color: '#4A5568', lineHeight: 1.6, marginTop: 6 }}&gt;&#10;          For each of the nine, answer in one line: is this a user goal, or a step inside one? Keep the goals; park the steps.&#10;        &lt;/Text&gt;&#10;      &lt;/Box&gt;&#10;      &lt;Box style={{ padding: '16px 18px', background: '#FFF6E0', borderRadius: 9, border: '1px solid #FFC107' }}&gt;&#10;        &lt;Text style={{ fontSize: 13, color: '#4A5568', lineHeight: 1.6 }}&gt;&#10;          &lt;Text style={{ fontWeight: 'bold', color: '#996F00' }}&gt;Work in your team. &lt;/Text&gt;&#10;          One page, two columns, twenty-five minutes. Answers on the next two pages — do not turn the page early.&#10;        &lt;/Text&gt;&#10;      &lt;/Box&gt;&#10;    &lt;/Box&gt;&#10;  &lt;/Box&gt;&#10;  &lt;Box style={{ height: 46, background: '#0E3F8C', padding: '0 40px', flexDirection: 'row', alignItems: 'center', justifyContent: 'center' }}&gt;&#10;    &lt;Text style={{ fontSize: 16, color: '#FFFFFF', fontWeight: '600' }}&gt;Twenty-five minutes. One page for the four of you — then each person defends one row you disagreed on.&lt;/Text&gt;&#10;  &lt;/Box&gt;&#10;&lt;/Slide&gt;"/>
         <p:cNvGrpSpPr/>
         <p:nvPr/>
       </p:nvGrpSpPr>
@@ -25306,8 +25306,8 @@
         </p:nvSpPr>
         <p:spPr>
           <a:xfrm rot="0" flipH="0" flipV="0">
-            <a:off x="2085975" y="6543675"/>
-            <a:ext cx="8029575" cy="190500"/>
+            <a:off x="2257425" y="6543675"/>
+            <a:ext cx="7686675" cy="190500"/>
           </a:xfrm>
           <a:prstGeom prst="rect"/>
         </p:spPr>
@@ -25327,7 +25327,7 @@
                 <a:latin typeface="Microsoft YaHei"/>
                 <a:ea typeface="Microsoft YaHei"/>
               </a:rPr>
-              <a:t>Twenty-five minutes. One page per team. Then we compare — and you will disagree about at least two of them.</a:t>
+              <a:t>Twenty-five minutes. One page for the four of you — then each person defends one row you disagreed on.</a:t>
             </a:r>
             <a:endParaRPr/>
           </a:p>
@@ -29379,7 +29379,7 @@
   <p:cSld>
     <p:spTree>
       <p:nvGrpSpPr>
-        <p:cNvPr id="639" name="" descr="&lt;Slide style={{ background: '#FFFFFF', padding: 0 }}&gt;&#10;  &lt;Box style={{ height: 72, background: '#1E4FA8', padding: '0 40px', flexDirection: 'row', alignItems: 'center', justifyContent: 'space-between' }}&gt;&#10;    &lt;Text style={{ fontSize: 15, color: '#B9CDF0', letterSpacing: 1 }}&gt;ISAD · INFORMATION SYSTEMS ANALYSIS &amp;amp; DESIGN&lt;/Text&gt;&#10;    &lt;Text style={{ fontSize: 15, color: '#B9CDF0' }}&gt;W04 · LAB · EXERCISE 4.2&lt;/Text&gt;&#10;  &lt;/Box&gt;&#10;  &lt;Box style={{ padding: '14px 40px 0 40px', flexDirection: 'row', alignItems: 'center', justifyContent: 'space-between' }}&gt;&#10;    &lt;Text style={{ fontSize: 29, fontWeight: 'bold', color: '#0E3F8C' }}&gt;Exercise 4.2 — Draw the Diagram&lt;/Text&gt;&#10;    &lt;Text style={{ fontSize: 14, color: '#1E4FA8', fontWeight: 'bold' }}&gt;35 / 38&lt;/Text&gt;&#10;  &lt;/Box&gt;&#10;  &lt;Box style={{ flex: 1, padding: '12px 40px 0 40px', flexDirection: 'row', gap: 24 }}&gt;&#10;    &lt;Box style={{ flex: 5, flexDirection: 'column', gap: 12 }}&gt;&#10;      &lt;Box style={{ padding: '18px 18px', background: '#F0F5FC', borderRadius: 10, borderLeft: '4px solid #1E4FA8' }}&gt;&#10;        &lt;Text style={{ fontSize: 17, fontWeight: 'bold', color: '#0E3F8C' }}&gt;The task&lt;/Text&gt;&#10;        &lt;Text style={{ fontSize: 13.5, color: '#4A5568', lineHeight: 1.65, marginTop: 6 }}&gt;&#10;          Draw one use case diagram for CampusBites from the Exercise 4.1 narrative. Six to ten use cases, the actors you listed, one &lt;Text style={{ fontWeight: 'bold', color: '#0E3F8C' }}&gt;&amp;lt;&amp;lt;include&amp;gt;&amp;gt;&lt;/Text&gt; and one &lt;Text style={{ fontWeight: 'bold', color: '#0E3F8C' }}&gt;&amp;lt;&amp;lt;extend&amp;gt;&amp;gt;&lt;/Text&gt;. Put the external systems outside the boundary box.&#10;        &lt;/Text&gt;&#10;      &lt;/Box&gt;&#10;      &lt;Box style={{ padding: '16px 18px', background: '#FFFFFF', borderRadius: 10, border: '1px solid #D6DCE5' }}&gt;&#10;        &lt;Text style={{ fontSize: 15.5, fontWeight: 'bold', color: '#0E3F8C' }}&gt;For each dashed arrow, write one sentence&lt;/Text&gt;&#10;        &lt;Text style={{ fontSize: 13, color: '#4A5568', lineHeight: 1.6, marginTop: 5 }}&gt;&#10;          State in words what the relationship means and why the arrow points that way. A diagram without the sentence is a drawing; with it, it is a model.&#10;        &lt;/Text&gt;&#10;      &lt;/Box&gt;&#10;      &lt;Box style={{ padding: '16px 18px', background: '#F7F9FC', borderRadius: 10, border: '1px dashed #D6DCE5' }}&gt;&#10;        &lt;Text style={{ fontSize: 13, color: '#8B97A8', lineHeight: 1.6 }}&gt;&#10;          Deliverable: &lt;Text style={{ color: '#0E3F8C', fontWeight: 'bold' }}&gt;docs/diagrams/use-case-v1.drawio&lt;/Text&gt; plus an exported PNG, committed before you leave. Source file and picture — both, as agreed in Week 03.&#10;        &lt;/Text&gt;&#10;      &lt;/Box&gt;&#10;    &lt;/Box&gt;&#10;    &lt;Box style={{ flex: 4, flexDirection: 'column', justifyContent: 'center' }}&gt;&#10;      &lt;Box style={{ padding: '16px 18px', background: '#FFF6E0', borderRadius: 10, borderLeft: '4px solid #FFC107', marginBottom: 10 }}&gt;&#10;        &lt;Text style={{ fontSize: 16, fontWeight: 'bold', color: '#996F00' }}&gt;Self-check before you hand it in&lt;/Text&gt;&#10;      &lt;/Box&gt;&#10;      {[&#10;        'Every ellipse is named verb plus object, in business words',&#10;        'Every use case belongs to exactly one primary actor',&#10;        'The boundary box is drawn, and its name is at the top',&#10;        'External systems sit outside the box and are drawn as boxes',&#10;        'No “Manage X” and no create-read-update-delete quartet',&#10;        'The include arrow leaves the base and arrives at what it needs',&#10;        'The extend arrow comes back from the extra to the base',&#10;        'Each dashed arrow carries a condition or a reason in words',&#10;      ].map((t) =&gt; (&#10;        &lt;Box key={t} style={{ flexDirection: 'row', alignItems: 'flex-start', gap: 9, marginBottom: 7 }}&gt;&#10;          &lt;Box style={{ width: 13, height: 13, borderRadius: 7, borderWidth: 1.4, borderColor: '#1E4FA8', marginTop: 3 }} /&gt;&#10;          &lt;Box style={{ flex: 1 }}&gt;&#10;            &lt;Text style={{ fontSize: 12.5, color: '#1A2230', lineHeight: 1.5 }}&gt;{t}&lt;/Text&gt;&#10;          &lt;/Box&gt;&#10;        &lt;/Box&gt;&#10;      ))}&#10;    &lt;/Box&gt;&#10;  &lt;/Box&gt;&#10;  &lt;Box style={{ height: 46, background: '#0E3F8C', padding: '0 40px', flexDirection: 'row', alignItems: 'center', justifyContent: 'center' }}&gt;&#10;    &lt;Text style={{ fontSize: 16, color: '#FFFFFF', fontWeight: '600' }}&gt;Thirty minutes to draw, fifteen to defend it to the other team. Answers on the next page.&lt;/Text&gt;&#10;  &lt;/Box&gt;&#10;&lt;/Slide&gt;"/>
+        <p:cNvPr id="639" name="" descr="&lt;Slide style={{ background: '#FFFFFF', padding: 0 }}&gt;&#10;  &lt;Box style={{ height: 72, background: '#1E4FA8', padding: '0 40px', flexDirection: 'row', alignItems: 'center', justifyContent: 'space-between' }}&gt;&#10;    &lt;Text style={{ fontSize: 15, color: '#B9CDF0', letterSpacing: 1 }}&gt;ISAD · INFORMATION SYSTEMS ANALYSIS &amp;amp; DESIGN&lt;/Text&gt;&#10;    &lt;Text style={{ fontSize: 15, color: '#B9CDF0' }}&gt;W04 · LAB · EXERCISE 4.2&lt;/Text&gt;&#10;  &lt;/Box&gt;&#10;  &lt;Box style={{ padding: '14px 40px 0 40px', flexDirection: 'row', alignItems: 'center', justifyContent: 'space-between' }}&gt;&#10;    &lt;Text style={{ fontSize: 29, fontWeight: 'bold', color: '#0E3F8C' }}&gt;Exercise 4.2 — Draw the Diagram&lt;/Text&gt;&#10;    &lt;Text style={{ fontSize: 14, color: '#1E4FA8', fontWeight: 'bold' }}&gt;35 / 38&lt;/Text&gt;&#10;  &lt;/Box&gt;&#10;  &lt;Box style={{ flex: 1, padding: '12px 40px 0 40px', flexDirection: 'row', gap: 24 }}&gt;&#10;    &lt;Box style={{ flex: 5, flexDirection: 'column', gap: 12 }}&gt;&#10;      &lt;Box style={{ padding: '18px 18px', background: '#F0F5FC', borderRadius: 10, borderLeft: '4px solid #1E4FA8' }}&gt;&#10;        &lt;Text style={{ fontSize: 17, fontWeight: 'bold', color: '#0E3F8C' }}&gt;The task&lt;/Text&gt;&#10;        &lt;Text style={{ fontSize: 13.5, color: '#4A5568', lineHeight: 1.65, marginTop: 6 }}&gt;&#10;          Draw one use case diagram for CampusBites from the Exercise 4.1 narrative. Six to ten use cases, the actors you listed, one &lt;Text style={{ fontWeight: 'bold', color: '#0E3F8C' }}&gt;&amp;lt;&amp;lt;include&amp;gt;&amp;gt;&lt;/Text&gt; and one &lt;Text style={{ fontWeight: 'bold', color: '#0E3F8C' }}&gt;&amp;lt;&amp;lt;extend&amp;gt;&amp;gt;&lt;/Text&gt;. Put the external systems outside the boundary box.&#10;        &lt;/Text&gt;&#10;      &lt;/Box&gt;&#10;      &lt;Box style={{ padding: '16px 18px', background: '#FFFFFF', borderRadius: 10, border: '1px solid #D6DCE5' }}&gt;&#10;        &lt;Text style={{ fontSize: 15.5, fontWeight: 'bold', color: '#0E3F8C' }}&gt;For each dashed arrow, write one sentence&lt;/Text&gt;&#10;        &lt;Text style={{ fontSize: 13, color: '#4A5568', lineHeight: 1.6, marginTop: 5 }}&gt;&#10;          State in words what the relationship means and why the arrow points that way. A diagram without the sentence is a drawing; with it, it is a model.&#10;        &lt;/Text&gt;&#10;      &lt;/Box&gt;&#10;      &lt;Box style={{ padding: '16px 18px', background: '#F7F9FC', borderRadius: 10, border: '1px dashed #D6DCE5' }}&gt;&#10;        &lt;Text style={{ fontSize: 13, color: '#8B97A8', lineHeight: 1.6 }}&gt;&#10;          Deliverable: &lt;Text style={{ color: '#0E3F8C', fontWeight: 'bold' }}&gt;docs/diagrams/use-case-v1.drawio&lt;/Text&gt; plus an exported PNG, committed before you leave. Source file and picture — both, as agreed in Week 03.&#10;        &lt;/Text&gt;&#10;      &lt;/Box&gt;&#10;    &lt;/Box&gt;&#10;    &lt;Box style={{ flex: 4, flexDirection: 'column', justifyContent: 'center' }}&gt;&#10;      &lt;Box style={{ padding: '16px 18px', background: '#FFF6E0', borderRadius: 10, borderLeft: '4px solid #FFC107', marginBottom: 10 }}&gt;&#10;        &lt;Text style={{ fontSize: 16, fontWeight: 'bold', color: '#996F00' }}&gt;Self-check before you hand it in&lt;/Text&gt;&#10;      &lt;/Box&gt;&#10;      {[&#10;        'Every ellipse is named verb plus object, in business words',&#10;        'Every use case belongs to exactly one primary actor',&#10;        'The boundary box is drawn, and its name is at the top',&#10;        'External systems sit outside the box and are drawn as boxes',&#10;        'No “Manage X” and no create-read-update-delete quartet',&#10;        'The include arrow leaves the base and arrives at what it needs',&#10;        'The extend arrow comes back from the extra to the base',&#10;        'Each dashed arrow carries a condition or a reason in words',&#10;      ].map((t) =&gt; (&#10;        &lt;Box key={t} style={{ flexDirection: 'row', alignItems: 'flex-start', gap: 9, marginBottom: 7 }}&gt;&#10;          &lt;Box style={{ width: 13, height: 13, borderRadius: 7, borderWidth: 1.4, borderColor: '#1E4FA8', marginTop: 3 }} /&gt;&#10;          &lt;Box style={{ flex: 1 }}&gt;&#10;            &lt;Text style={{ fontSize: 12.5, color: '#1A2230', lineHeight: 1.5 }}&gt;{t}&lt;/Text&gt;&#10;          &lt;/Box&gt;&#10;        &lt;/Box&gt;&#10;      ))}&#10;    &lt;/Box&gt;&#10;  &lt;/Box&gt;&#10;  &lt;Box style={{ height: 46, background: '#0E3F8C', padding: '0 40px', flexDirection: 'row', alignItems: 'center', justifyContent: 'center' }}&gt;&#10;    &lt;Text style={{ fontSize: 16, color: '#FFFFFF', fontWeight: '600' }}&gt;Thirty minutes to draw, fifteen to defend it to the instructor, who is playing the client today. Answers on the next page.&lt;/Text&gt;&#10;  &lt;/Box&gt;&#10;&lt;/Slide&gt;"/>
         <p:cNvGrpSpPr/>
         <p:nvPr/>
       </p:nvGrpSpPr>
@@ -30619,8 +30619,8 @@
         </p:nvSpPr>
         <p:spPr>
           <a:xfrm rot="0" flipH="0" flipV="0">
-            <a:off x="2933700" y="6543675"/>
-            <a:ext cx="6334125" cy="190500"/>
+            <a:off x="1828800" y="6543675"/>
+            <a:ext cx="8543925" cy="190500"/>
           </a:xfrm>
           <a:prstGeom prst="rect"/>
         </p:spPr>
@@ -30640,7 +30640,7 @@
                 <a:latin typeface="Microsoft YaHei"/>
                 <a:ea typeface="Microsoft YaHei"/>
               </a:rPr>
-              <a:t>Thirty minutes to draw, fifteen to defend it to the other team. Answers on the next page.</a:t>
+              <a:t>Thirty minutes to draw, fifteen to defend it to the instructor, who is playing the client today. Answers on the next page.</a:t>
             </a:r>
             <a:endParaRPr/>
           </a:p>
@@ -30967,7 +30967,7 @@
   <p:cSld>
     <p:spTree>
       <p:nvGrpSpPr>
-        <p:cNvPr id="686" name="" descr="&lt;Slide style={{ background: '#FFFFFF', padding: 0 }}&gt;&#10;  &lt;Box style={{ height: 72, background: '#1E4FA8', padding: '0 40px', flexDirection: 'row', alignItems: 'center', justifyContent: 'space-between' }}&gt;&#10;    &lt;Text style={{ fontSize: 15, color: '#B9CDF0', letterSpacing: 1 }}&gt;ISAD · INFORMATION SYSTEMS ANALYSIS &amp;amp; DESIGN&lt;/Text&gt;&#10;    &lt;Text style={{ fontSize: 15, color: '#B9CDF0' }}&gt;W04 · HOMEWORK &amp;amp; M1&lt;/Text&gt;&#10;  &lt;/Box&gt;&#10;  &lt;Box style={{ padding: '14px 40px 0 40px', flexDirection: 'row', alignItems: 'center', justifyContent: 'space-between' }}&gt;&#10;    &lt;Text style={{ fontSize: 29, fontWeight: 'bold', color: '#0E3F8C' }}&gt;Homework &amp;amp; Project M1&lt;/Text&gt;&#10;    &lt;Text style={{ fontSize: 14, color: '#1E4FA8', fontWeight: 'bold' }}&gt;37 / 38&lt;/Text&gt;&#10;  &lt;/Box&gt;&#10;  &lt;Box style={{ flex: 1, padding: '12px 40px 0 40px', flexDirection: 'row', gap: 20 }}&gt;&#10;    &lt;Box style={{ flex: 1, flexDirection: 'column', gap: 10 }}&gt;&#10;      &lt;Box style={{ flexDirection: 'row', alignItems: 'center', gap: 9, marginBottom: 2 }}&gt;&#10;        &lt;FAIcon name='pen-fancy' style={{ fill: '#1E4FA8', width: 18, height: 18 }} /&gt;&#10;        &lt;Text style={{ fontSize: 16.5, fontWeight: 'bold', color: '#0E3F8C' }}&gt;Before next Monday&lt;/Text&gt;&#10;      &lt;/Box&gt;&#10;      {[&#10;        'Finish the diagram — source file and PNG, in docs/diagrams/, pushed',&#10;        'Write two use case briefs: Place Order and one you choose',&#10;        'Read Larman Chapter 6 (use cases) — twenty pages, not all of it',&#10;        'Bring one question the narrative could not answer',&#10;      ].map((t) =&gt; (&#10;        &lt;Box key={t} style={{ flexDirection: 'row', alignItems: 'flex-start', gap: 9 }}&gt;&#10;          &lt;Box style={{ width: 13, height: 13, borderRadius: 7, borderWidth: 1.4, borderColor: '#1E4FA8', marginTop: 3 }} /&gt;&#10;          &lt;Box style={{ flex: 1 }}&gt;&#10;            &lt;Text style={{ fontSize: 13, color: '#1A2230', lineHeight: 1.55 }}&gt;{t}&lt;/Text&gt;&#10;          &lt;/Box&gt;&#10;        &lt;/Box&gt;&#10;      ))}&#10;      &lt;Box style={{ padding: '12px 14px', background: '#FFF6E0', borderRadius: 8, borderLeft: '3px solid #FFC107', marginTop: 4 }}&gt;&#10;        &lt;Text style={{ fontSize: 12.2, color: '#4A5568', lineHeight: 1.55 }}&gt;&#10;          A brief is half a page: the goal in one sentence, the primary actor, and the one thing that can go wrong. Full specifications are Week 05.&#10;        &lt;/Text&gt;&#10;      &lt;/Box&gt;&#10;    &lt;/Box&gt;&#10;    &lt;Box style={{ width: 20 }} /&gt;&#10;    &lt;Box style={{ flex: 1, flexDirection: 'column', gap: 10 }}&gt;&#10;      &lt;Box style={{ flexDirection: 'row', alignItems: 'center', gap: 9, marginBottom: 2 }}&gt;&#10;        &lt;FAIcon name='folder' style={{ fill: '#1E4FA8', width: 18, height: 18 }} /&gt;&#10;        &lt;Text style={{ fontSize: 16.5, fontWeight: 'bold', color: '#0E3F8C' }}&gt;Milestone M1 — due Sunday 4 October&lt;/Text&gt;&#10;      &lt;/Box&gt;&#10;      {[&#10;        'A requirements list: functional and non-functional, each testable',&#10;        'The use case diagram — source file, PNG, and one sentence per dashed arrow',&#10;        'Two use case briefs, written in your own words',&#10;      ].map((t) =&gt; (&#10;        &lt;Box key={t} style={{ padding: '13px 15px', background: '#F0F5FC', borderRadius: 8, borderLeft: '3px solid #1E4FA8' }}&gt;&#10;          &lt;Text style={{ fontSize: 13, color: '#1A2230', lineHeight: 1.55 }}&gt;{t}&lt;/Text&gt;&#10;        &lt;/Box&gt;&#10;      ))}&#10;      &lt;Box style={{ flexDirection: 'row', alignItems: 'center', gap: 9, marginTop: 6, marginBottom: 2 }}&gt;&#10;        &lt;FAIcon name='exclamation-triangle' style={{ fill: '#D9534F', width: 17, height: 17 }} /&gt;&#10;        &lt;Text style={{ fontSize: 16.5, fontWeight: 'bold', color: '#D9534F' }}&gt;How it is submitted&lt;/Text&gt;&#10;      &lt;/Box&gt;&#10;      &lt;Box style={{ padding: '14px 16px', background: '#FDF3F3', borderRadius: 9, border: '1px solid #D9534F' }}&gt;&#10;        &lt;Text style={{ fontSize: 13, color: '#1A2230', lineHeight: 1.6 }}&gt;&#10;          Push to GitHub, then tag it &lt;Text style={{ fontWeight: 'bold', color: '#D9534F' }}&gt;m1&lt;/Text&gt;. A push without a tag is not a submission — the tag is the snapshot that gets graded.&#10;        &lt;/Text&gt;&#10;        &lt;Text style={{ fontSize: 12, color: '#8B97A8', lineHeight: 1.55, marginTop: 6 }}&gt;&#10;          git tag -a m1 -m &quot;M1: requirements, use case diagram, two briefs&quot; &amp;amp;&amp;amp; git push origin m1&#10;        &lt;/Text&gt;&#10;        &lt;Text style={{ fontSize: 12, color: '#8B97A8', lineHeight: 1.55, marginTop: 4 }}&gt;&#10;          Check it landed: git ls-remote --tags origin&#10;        &lt;/Text&gt;&#10;      &lt;/Box&gt;&#10;    &lt;/Box&gt;&#10;  &lt;/Box&gt;&#10;  &lt;Box style={{ height: 46, background: '#0E3F8C', padding: '0 40px', flexDirection: 'row', alignItems: 'center', justifyContent: 'center' }}&gt;&#10;    &lt;Text style={{ fontSize: 16, color: '#FFFFFF', fontWeight: '600' }}&gt;Four weeks to M1. The diagram is due next week; the briefs and the requirements list follow.&lt;/Text&gt;&#10;  &lt;/Box&gt;&#10;&lt;/Slide&gt;"/>
+        <p:cNvPr id="686" name="" descr="&lt;Slide style={{ background: '#FFFFFF', padding: 0 }}&gt;&#10;  &lt;Box style={{ height: 72, background: '#1E4FA8', padding: '0 40px', flexDirection: 'row', alignItems: 'center', justifyContent: 'space-between' }}&gt;&#10;    &lt;Text style={{ fontSize: 15, color: '#B9CDF0', letterSpacing: 1 }}&gt;ISAD · INFORMATION SYSTEMS ANALYSIS &amp;amp; DESIGN&lt;/Text&gt;&#10;    &lt;Text style={{ fontSize: 15, color: '#B9CDF0' }}&gt;W04 · HOMEWORK &amp;amp; M1&lt;/Text&gt;&#10;  &lt;/Box&gt;&#10;  &lt;Box style={{ padding: '14px 40px 0 40px', flexDirection: 'row', alignItems: 'center', justifyContent: 'space-between' }}&gt;&#10;    &lt;Text style={{ fontSize: 29, fontWeight: 'bold', color: '#0E3F8C' }}&gt;Homework &amp;amp; Project M1&lt;/Text&gt;&#10;    &lt;Text style={{ fontSize: 14, color: '#1E4FA8', fontWeight: 'bold' }}&gt;37 / 38&lt;/Text&gt;&#10;  &lt;/Box&gt;&#10;  &lt;Box style={{ flex: 1, padding: '12px 40px 0 40px', flexDirection: 'row', gap: 20 }}&gt;&#10;    &lt;Box style={{ flex: 1, flexDirection: 'column', gap: 10 }}&gt;&#10;      &lt;Box style={{ flexDirection: 'row', alignItems: 'center', gap: 9, marginBottom: 2 }}&gt;&#10;        &lt;FAIcon name='pen-fancy' style={{ fill: '#1E4FA8', width: 18, height: 18 }} /&gt;&#10;        &lt;Text style={{ fontSize: 16.5, fontWeight: 'bold', color: '#0E3F8C' }}&gt;Before next Monday&lt;/Text&gt;&#10;      &lt;/Box&gt;&#10;      {[&#10;        'Finish the diagram — source file and PNG, in docs/diagrams/, pushed',&#10;        'Write two use case briefs: Place Order and one you choose',&#10;        'Read Larman Chapter 6 (use cases) — twenty pages, not all of it',&#10;        'Bring one question the narrative could not answer',&#10;      ].map((t) =&gt; (&#10;        &lt;Box key={t} style={{ flexDirection: 'row', alignItems: 'flex-start', gap: 9 }}&gt;&#10;          &lt;Box style={{ width: 13, height: 13, borderRadius: 7, borderWidth: 1.4, borderColor: '#1E4FA8', marginTop: 3 }} /&gt;&#10;          &lt;Box style={{ flex: 1 }}&gt;&#10;            &lt;Text style={{ fontSize: 13, color: '#1A2230', lineHeight: 1.55 }}&gt;{t}&lt;/Text&gt;&#10;          &lt;/Box&gt;&#10;        &lt;/Box&gt;&#10;      ))}&#10;      &lt;Box style={{ padding: '12px 14px', background: '#FFF6E0', borderRadius: 8, borderLeft: '3px solid #FFC107', marginTop: 4 }}&gt;&#10;        &lt;Text style={{ fontSize: 12.2, color: '#4A5568', lineHeight: 1.55 }}&gt;&#10;          A brief is half a page: the goal in one sentence, the primary actor, and the one thing that can go wrong. Full specifications are Week 05.&#10;        &lt;/Text&gt;&#10;      &lt;/Box&gt;&#10;    &lt;/Box&gt;&#10;    &lt;Box style={{ width: 20 }} /&gt;&#10;    &lt;Box style={{ flex: 1, flexDirection: 'column', gap: 10 }}&gt;&#10;      &lt;Box style={{ flexDirection: 'row', alignItems: 'center', gap: 9, marginBottom: 2 }}&gt;&#10;        &lt;FAIcon name='folder' style={{ fill: '#1E4FA8', width: 18, height: 18 }} /&gt;&#10;        &lt;Text style={{ fontSize: 16.5, fontWeight: 'bold', color: '#0E3F8C' }}&gt;Milestone M1 — due Sunday 4 October&lt;/Text&gt;&#10;      &lt;/Box&gt;&#10;      {[&#10;        'A requirements list: functional and non-functional, each testable',&#10;        'The use case diagram — source file, PNG, and one sentence per dashed arrow',&#10;        'Two use case briefs, written in your own words',&#10;      ].map((t) =&gt; (&#10;        &lt;Box key={t} style={{ padding: '13px 15px', background: '#F0F5FC', borderRadius: 8, borderLeft: '3px solid #1E4FA8' }}&gt;&#10;          &lt;Text style={{ fontSize: 13, color: '#1A2230', lineHeight: 1.55 }}&gt;{t}&lt;/Text&gt;&#10;        &lt;/Box&gt;&#10;      ))}&#10;      &lt;Box style={{ flexDirection: 'row', alignItems: 'center', gap: 9, marginTop: 6, marginBottom: 2 }}&gt;&#10;        &lt;FAIcon name='exclamation-triangle' style={{ fill: '#D9534F', width: 17, height: 17 }} /&gt;&#10;        &lt;Text style={{ fontSize: 16.5, fontWeight: 'bold', color: '#D9534F' }}&gt;How it is submitted&lt;/Text&gt;&#10;      &lt;/Box&gt;&#10;      &lt;Box style={{ padding: '14px 16px', background: '#FDF3F3', borderRadius: 9, border: '1px solid #D9534F' }}&gt;&#10;        &lt;Text style={{ fontSize: 13, color: '#1A2230', lineHeight: 1.6 }}&gt;&#10;          Push to GitHub, then tag it &lt;Text style={{ fontWeight: 'bold', color: '#D9534F' }}&gt;m1&lt;/Text&gt;. A push without a tag is not a submission — the tag is the snapshot that gets graded.&#10;        &lt;/Text&gt;&#10;        &lt;Text style={{ fontSize: 12, color: '#8B97A8', lineHeight: 1.55, marginTop: 6 }}&gt;&#10;          git tag -a m1 -m &quot;M1: requirements, use case diagram, two briefs&quot; &amp;amp;&amp;amp; git push origin m1&#10;        &lt;/Text&gt;&#10;        &lt;Text style={{ fontSize: 12, color: '#8B97A8', lineHeight: 1.55, marginTop: 4 }}&gt;&#10;          Check it landed: git ls-remote --tags origin&#10;        &lt;/Text&gt;&#10;      &lt;/Box&gt;&#10;    &lt;/Box&gt;&#10;  &lt;/Box&gt;&#10;  &lt;Box style={{ height: 46, background: '#0E3F8C', padding: '0 40px', flexDirection: 'row', alignItems: 'center', justifyContent: 'center' }}&gt;&#10;    &lt;Text style={{ fontSize: 16, color: '#FFFFFF', fontWeight: '600' }}&gt;M1 closes on Sunday 4 October. The diagram is due next week; the briefs and the requirements list follow.&lt;/Text&gt;&#10;  &lt;/Box&gt;&#10;&lt;/Slide&gt;"/>
         <p:cNvGrpSpPr/>
         <p:nvPr/>
       </p:nvGrpSpPr>
@@ -32281,8 +32281,8 @@
         </p:nvSpPr>
         <p:spPr>
           <a:xfrm rot="0" flipH="0" flipV="0">
-            <a:off x="2762250" y="6543675"/>
-            <a:ext cx="6677025" cy="190500"/>
+            <a:off x="2247900" y="6543675"/>
+            <a:ext cx="7696200" cy="190500"/>
           </a:xfrm>
           <a:prstGeom prst="rect"/>
         </p:spPr>
@@ -32302,7 +32302,7 @@
                 <a:latin typeface="Microsoft YaHei"/>
                 <a:ea typeface="Microsoft YaHei"/>
               </a:rPr>
-              <a:t>Four weeks to M1. The diagram is due next week; the briefs and the requirements list follow.</a:t>
+              <a:t>M1 closes on Sunday 4 October. The diagram is due next week; the briefs and the requirements list follow.</a:t>
             </a:r>
             <a:endParaRPr/>
           </a:p>

</xml_diff>